<commit_message>
Present the live Azure deployment across every deliverable, and add CI and a licence
- README: badges, links, what it does, an architecture diagram, the stack, and how to run, test and deploy
- Phase 2 submission, its official-template slides, the deck, the website and the technical guide: the app runs live on Microsoft Azure as one Docker image, and the pilot runs the same image with demonstration mode off
- Corrected figures: 112 of 112 translations in four languages (not 140 in five), 30 automated tests, current code sizes, a 12-slide deck
- Technical guide: the real stack (Django and React in CARE, Sarvam AI layer) in place of the Round 1 plan
- Engine tests in poc/tests, run by GitHub Actions on every push
- MIT licence, the same as CARE's

Co-Authored-By: Claude Opus 5.5 <noreply@anthropic.com>
</commit_message>
<xml_diff>
--- a/docs/RAD-SMART_Phase2_Submission.pptx
+++ b/docs/RAD-SMART_Phase2_Submission.pptx
@@ -13382,7 +13382,7 @@
                 </a:solidFill>
                 <a:latin typeface="Calibri"/>
               </a:rPr>
-              <a:t>Installs as a CARE plugin on the hospital's own server; about ₹1 a message to run</a:t>
+              <a:t>Live on Microsoft Azure today; the pilot runs the same Docker image; about ₹1 a message to run</a:t>
             </a:r>
           </a:p>
         </p:txBody>
@@ -13431,7 +13431,7 @@
                 </a:solidFill>
                 <a:latin typeface="Arial"/>
               </a:rPr>
-              <a:t>WHAT A PILOT NEEDS</a:t>
+              <a:t>RUNNING TODAY, AND WHAT A PILOT NEEDS</a:t>
             </a:r>
           </a:p>
           <a:p>
@@ -13449,13 +13449,55 @@
               <a:buChar char="•"/>
             </a:pPr>
             <a:r>
+              <a:rPr sz="1200" b="1" i="0">
+                <a:solidFill>
+                  <a:srgbClr val="232F3E"/>
+                </a:solidFill>
+                <a:latin typeface="Calibri"/>
+              </a:rPr>
+              <a:t>Live now:</a:t>
+            </a:r>
+            <a:r>
               <a:rPr sz="1200" b="0" i="0">
                 <a:solidFill>
                   <a:srgbClr val="232F3E"/>
                 </a:solidFill>
                 <a:latin typeface="Calibri"/>
               </a:rPr>
-              <a:t>A CARE instance (the hospital's, or a VM running CARE with Docker Compose); RAD-SMART installs as a backend and a frontend plugin</a:t>
+              <a:t> one Docker image (CARE's production build with both plugins) on Azure Container Apps, with PostgreSQL, daily backups and HTTPS; one script deploys it</a:t>
+            </a:r>
+          </a:p>
+          <a:p>
+            <a:pPr algn="l" marL="155448" indent="-155448">
+              <a:lnSpc>
+                <a:spcPct val="100000"/>
+              </a:lnSpc>
+              <a:spcAft>
+                <a:spcPts val="300"/>
+              </a:spcAft>
+              <a:buClr>
+                <a:srgbClr val="1F3DA9"/>
+              </a:buClr>
+              <a:buFont typeface="Arial"/>
+              <a:buChar char="•"/>
+            </a:pPr>
+            <a:r>
+              <a:rPr sz="1200" b="1" i="0">
+                <a:solidFill>
+                  <a:srgbClr val="232F3E"/>
+                </a:solidFill>
+                <a:latin typeface="Calibri"/>
+              </a:rPr>
+              <a:t>Pilot:</a:t>
+            </a:r>
+            <a:r>
+              <a:rPr sz="1200" b="0" i="0">
+                <a:solidFill>
+                  <a:srgbClr val="232F3E"/>
+                </a:solidFill>
+                <a:latin typeface="Calibri"/>
+              </a:rPr>
+              <a:t> the same image with demonstration mode off, on the hospital's server beside its CARE, or in Azure Central India so data stays in India</a:t>
             </a:r>
           </a:p>
           <a:p>
@@ -13664,7 +13706,7 @@
                 <a:gridCol w="4416552"/>
                 <a:gridCol w="1417320"/>
               </a:tblGrid>
-              <a:tr h="315883">
+              <a:tr h="289560">
                 <a:tc>
                   <a:txBody>
                     <a:bodyPr wrap="square"/>
@@ -13712,7 +13754,7 @@
                   </a:tcPr>
                 </a:tc>
               </a:tr>
-              <a:tr h="315883">
+              <a:tr h="289560">
                 <a:tc gridSpan="2">
                   <a:txBody>
                     <a:bodyPr wrap="square"/>
@@ -13745,7 +13787,7 @@
                   <a:tcPr/>
                 </a:tc>
               </a:tr>
-              <a:tr h="315883">
+              <a:tr h="289560">
                 <a:tc>
                   <a:txBody>
                     <a:bodyPr wrap="square"/>
@@ -13793,7 +13835,7 @@
                   </a:tcPr>
                 </a:tc>
               </a:tr>
-              <a:tr h="315883">
+              <a:tr h="289560">
                 <a:tc>
                   <a:txBody>
                     <a:bodyPr wrap="square"/>
@@ -13841,7 +13883,7 @@
                   </a:tcPr>
                 </a:tc>
               </a:tr>
-              <a:tr h="315883">
+              <a:tr h="289560">
                 <a:tc>
                   <a:txBody>
                     <a:bodyPr wrap="square"/>
@@ -13889,7 +13931,7 @@
                   </a:tcPr>
                 </a:tc>
               </a:tr>
-              <a:tr h="315883">
+              <a:tr h="289560">
                 <a:tc>
                   <a:txBody>
                     <a:bodyPr wrap="square"/>
@@ -13937,7 +13979,7 @@
                   </a:tcPr>
                 </a:tc>
               </a:tr>
-              <a:tr h="315883">
+              <a:tr h="289560">
                 <a:tc gridSpan="2">
                   <a:txBody>
                     <a:bodyPr wrap="square"/>
@@ -13970,7 +14012,7 @@
                   <a:tcPr/>
                 </a:tc>
               </a:tr>
-              <a:tr h="315883">
+              <a:tr h="289560">
                 <a:tc>
                   <a:txBody>
                     <a:bodyPr wrap="square"/>
@@ -14018,7 +14060,7 @@
                   </a:tcPr>
                 </a:tc>
               </a:tr>
-              <a:tr h="315883">
+              <a:tr h="289560">
                 <a:tc>
                   <a:txBody>
                     <a:bodyPr wrap="square"/>
@@ -14066,7 +14108,7 @@
                   </a:tcPr>
                 </a:tc>
               </a:tr>
-              <a:tr h="315883">
+              <a:tr h="289560">
                 <a:tc>
                   <a:txBody>
                     <a:bodyPr wrap="square"/>
@@ -14114,7 +14156,7 @@
                   </a:tcPr>
                 </a:tc>
               </a:tr>
-              <a:tr h="315890">
+              <a:tr h="289560">
                 <a:tc>
                   <a:txBody>
                     <a:bodyPr wrap="square"/>
@@ -14162,6 +14204,54 @@
                   </a:tcPr>
                 </a:tc>
               </a:tr>
+              <a:tr h="289560">
+                <a:tc>
+                  <a:txBody>
+                    <a:bodyPr wrap="square"/>
+                    <a:lstStyle/>
+                    <a:p>
+                      <a:pPr algn="l"/>
+                      <a:r>
+                        <a:rPr sz="1150" b="0" i="0">
+                          <a:solidFill>
+                            <a:srgbClr val="232F3E"/>
+                          </a:solidFill>
+                          <a:latin typeface="Calibri"/>
+                        </a:rPr>
+                        <a:t>Or Azure in India instead of a server, per month</a:t>
+                      </a:r>
+                    </a:p>
+                  </a:txBody>
+                  <a:tcPr marL="91440" marR="91440" marT="36576" marB="36576" anchor="ctr">
+                    <a:solidFill>
+                      <a:srgbClr val="FFFFFF"/>
+                    </a:solidFill>
+                  </a:tcPr>
+                </a:tc>
+                <a:tc>
+                  <a:txBody>
+                    <a:bodyPr wrap="square"/>
+                    <a:lstStyle/>
+                    <a:p>
+                      <a:pPr algn="r"/>
+                      <a:r>
+                        <a:rPr sz="1150" b="1" i="0">
+                          <a:solidFill>
+                            <a:srgbClr val="232F3E"/>
+                          </a:solidFill>
+                          <a:latin typeface="Calibri"/>
+                        </a:rPr>
+                        <a:t>about 4,000 – 6,000</a:t>
+                      </a:r>
+                    </a:p>
+                  </a:txBody>
+                  <a:tcPr marL="91440" marR="91440" marT="36576" marB="36576" anchor="ctr">
+                    <a:solidFill>
+                      <a:srgbClr val="FFFFFF"/>
+                    </a:solidFill>
+                  </a:tcPr>
+                </a:tc>
+              </a:tr>
             </a:tbl>
           </a:graphicData>
         </a:graphic>
@@ -16434,7 +16524,7 @@
                 </a:solidFill>
                 <a:latin typeface="Calibri"/>
               </a:rPr>
-              <a:t>20 automated safety tests now guard all of this</a:t>
+              <a:t>30 automated tests now guard all of this</a:t>
             </a:r>
           </a:p>
         </p:txBody>
@@ -22723,7 +22813,7 @@
                 </a:solidFill>
                 <a:latin typeface="Calibri"/>
               </a:rPr>
-              <a:t>A working application inside CARE today, shown here with synthetic patients</a:t>
+              <a:t>A working application inside CARE, live on Microsoft Azure, shown here with synthetic patients</a:t>
             </a:r>
           </a:p>
         </p:txBody>
@@ -23151,6 +23241,26 @@
                 <a:latin typeface="Calibri"/>
                 <a:hlinkClick r:id="rId9"/>
               </a:rPr>
+              <a:t>Try the live app on Microsoft Azure</a:t>
+            </a:r>
+          </a:p>
+          <a:p>
+            <a:pPr algn="l">
+              <a:lnSpc>
+                <a:spcPct val="100000"/>
+              </a:lnSpc>
+              <a:spcAft>
+                <a:spcPts val="300"/>
+              </a:spcAft>
+            </a:pPr>
+            <a:r>
+              <a:rPr sz="1200" b="0" i="0">
+                <a:solidFill>
+                  <a:srgbClr val="1F3DA9"/>
+                </a:solidFill>
+                <a:latin typeface="Calibri"/>
+                <a:hlinkClick r:id="rId10"/>
+              </a:rPr>
               <a:t>Code on GitHub</a:t>
             </a:r>
           </a:p>
@@ -23165,7 +23275,7 @@
           <p:nvPr/>
         </p:nvPicPr>
         <p:blipFill>
-          <a:blip r:embed="rId10"/>
+          <a:blip r:embed="rId11"/>
           <a:stretch>
             <a:fillRect/>
           </a:stretch>
@@ -24650,7 +24760,7 @@
                 </a:solidFill>
                 <a:latin typeface="Calibri"/>
               </a:rPr>
-              <a:t>Docker Compose · about 10,600 lines of code</a:t>
+              <a:t>Docker, live on Microsoft Azure · about 11,000 lines of code</a:t>
             </a:r>
           </a:p>
         </p:txBody>
@@ -24852,7 +24962,7 @@
                 </a:solidFill>
                 <a:latin typeface="Calibri"/>
               </a:rPr>
-              <a:t>From a Round 1 engine to a working CARE application with a patient side (sprint: 5 Oct – 8 Nov)</a:t>
+              <a:t>From a Round 1 engine to a CARE application with a patient side, live on Azure (sprint: 5 Oct – 8 Nov)</a:t>
             </a:r>
           </a:p>
         </p:txBody>
@@ -25274,14 +25384,14 @@
                 </a:solidFill>
                 <a:latin typeface="Arial"/>
               </a:rPr>
-              <a:t>21 Oct</a:t>
-            </a:r>
-          </a:p>
-        </p:txBody>
-      </p:sp>
-      <p:sp>
-        <p:nvSpPr>
-          <p:cNvPr id="162" name="Milestone 21 Oct"/>
+              <a:t>24 Oct</a:t>
+            </a:r>
+          </a:p>
+        </p:txBody>
+      </p:sp>
+      <p:sp>
+        <p:nvSpPr>
+          <p:cNvPr id="162" name="Milestone 24 Oct"/>
           <p:cNvSpPr/>
           <p:nvPr/>
         </p:nvSpPr>
@@ -25347,7 +25457,7 @@
                 </a:solidFill>
                 <a:latin typeface="Calibri"/>
               </a:rPr>
-              <a:t>Technical guide and maths notes for the department</a:t>
+              <a:t>Department's second answers built in; a working app inside CARE</a:t>
             </a:r>
           </a:p>
         </p:txBody>
@@ -25389,14 +25499,14 @@
                 </a:solidFill>
                 <a:latin typeface="Arial"/>
               </a:rPr>
-              <a:t>24 Oct</a:t>
-            </a:r>
-          </a:p>
-        </p:txBody>
-      </p:sp>
-      <p:sp>
-        <p:nvSpPr>
-          <p:cNvPr id="165" name="Milestone 24 Oct"/>
+              <a:t>25 Oct</a:t>
+            </a:r>
+          </a:p>
+        </p:txBody>
+      </p:sp>
+      <p:sp>
+        <p:nvSpPr>
+          <p:cNvPr id="165" name="Milestone 25 Oct"/>
           <p:cNvSpPr/>
           <p:nvPr/>
         </p:nvSpPr>
@@ -25462,7 +25572,7 @@
                 </a:solidFill>
                 <a:latin typeface="Calibri"/>
               </a:rPr>
-              <a:t>Department's second answers built in; a working app inside CARE</a:t>
+              <a:t>Sarvam AI layer, patient page, QR check-in, evaluation, narrated video</a:t>
             </a:r>
           </a:p>
         </p:txBody>
@@ -25504,14 +25614,14 @@
                 </a:solidFill>
                 <a:latin typeface="Arial"/>
               </a:rPr>
-              <a:t>25 Oct</a:t>
-            </a:r>
-          </a:p>
-        </p:txBody>
-      </p:sp>
-      <p:sp>
-        <p:nvSpPr>
-          <p:cNvPr id="168" name="Milestone 25 Oct"/>
+              <a:t>26 Oct</a:t>
+            </a:r>
+          </a:p>
+        </p:txBody>
+      </p:sp>
+      <p:sp>
+        <p:nvSpPr>
+          <p:cNvPr id="168" name="Milestone 26 Oct"/>
           <p:cNvSpPr/>
           <p:nvPr/>
         </p:nvSpPr>
@@ -25577,7 +25687,7 @@
                 </a:solidFill>
                 <a:latin typeface="Calibri"/>
               </a:rPr>
-              <a:t>Sarvam AI layer, patient page, QR check-in, evaluation, narrated video</a:t>
+              <a:t>Live on Microsoft Azure in Docker, open to anyone; video recorded on it</a:t>
             </a:r>
           </a:p>
         </p:txBody>
@@ -25933,7 +26043,31 @@
                 </a:solidFill>
                 <a:latin typeface="Calibri"/>
               </a:rPr>
-              <a:t>Insights · 20 automated safety tests</a:t>
+              <a:t>Insights · 30 automated tests</a:t>
+            </a:r>
+          </a:p>
+          <a:p>
+            <a:pPr algn="l" marL="155448" indent="-155448">
+              <a:lnSpc>
+                <a:spcPct val="100000"/>
+              </a:lnSpc>
+              <a:spcAft>
+                <a:spcPts val="300"/>
+              </a:spcAft>
+              <a:buClr>
+                <a:srgbClr val="0D8743"/>
+              </a:buClr>
+              <a:buFont typeface="Arial"/>
+              <a:buChar char="•"/>
+            </a:pPr>
+            <a:r>
+              <a:rPr sz="1200" b="0" i="0">
+                <a:solidFill>
+                  <a:srgbClr val="232F3E"/>
+                </a:solidFill>
+                <a:latin typeface="Calibri"/>
+              </a:rPr>
+              <a:t>Live on Microsoft Azure in one Docker image; anyone can try it</a:t>
             </a:r>
           </a:p>
         </p:txBody>

</xml_diff>